<commit_message>
fix for login for tuple to guuid
</commit_message>
<xml_diff>
--- a/docs/POC.pptx
+++ b/docs/POC.pptx
@@ -321,7 +321,7 @@
           <a:p>
             <a:fld id="{5BCAD085-E8A6-8845-BD4E-CB4CCA059FC4}" type="datetimeFigureOut">
               <a:rPr lang="en-US" smtClean="0"/>
-              <a:t>3/17/2026</a:t>
+              <a:t>3/18/2026</a:t>
             </a:fld>
             <a:endParaRPr lang="en-US"/>
           </a:p>
@@ -489,7 +489,7 @@
           <a:p>
             <a:fld id="{5BCAD085-E8A6-8845-BD4E-CB4CCA059FC4}" type="datetimeFigureOut">
               <a:rPr lang="en-US" smtClean="0"/>
-              <a:t>3/17/2026</a:t>
+              <a:t>3/18/2026</a:t>
             </a:fld>
             <a:endParaRPr lang="en-US"/>
           </a:p>
@@ -667,7 +667,7 @@
           <a:p>
             <a:fld id="{5BCAD085-E8A6-8845-BD4E-CB4CCA059FC4}" type="datetimeFigureOut">
               <a:rPr lang="en-US" smtClean="0"/>
-              <a:t>3/17/2026</a:t>
+              <a:t>3/18/2026</a:t>
             </a:fld>
             <a:endParaRPr lang="en-US"/>
           </a:p>
@@ -835,7 +835,7 @@
           <a:p>
             <a:fld id="{5BCAD085-E8A6-8845-BD4E-CB4CCA059FC4}" type="datetimeFigureOut">
               <a:rPr lang="en-US" smtClean="0"/>
-              <a:t>3/17/2026</a:t>
+              <a:t>3/18/2026</a:t>
             </a:fld>
             <a:endParaRPr lang="en-US"/>
           </a:p>
@@ -1080,7 +1080,7 @@
           <a:p>
             <a:fld id="{5BCAD085-E8A6-8845-BD4E-CB4CCA059FC4}" type="datetimeFigureOut">
               <a:rPr lang="en-US" smtClean="0"/>
-              <a:t>3/17/2026</a:t>
+              <a:t>3/18/2026</a:t>
             </a:fld>
             <a:endParaRPr lang="en-US"/>
           </a:p>
@@ -1365,7 +1365,7 @@
           <a:p>
             <a:fld id="{5BCAD085-E8A6-8845-BD4E-CB4CCA059FC4}" type="datetimeFigureOut">
               <a:rPr lang="en-US" smtClean="0"/>
-              <a:t>3/17/2026</a:t>
+              <a:t>3/18/2026</a:t>
             </a:fld>
             <a:endParaRPr lang="en-US"/>
           </a:p>
@@ -1784,7 +1784,7 @@
           <a:p>
             <a:fld id="{5BCAD085-E8A6-8845-BD4E-CB4CCA059FC4}" type="datetimeFigureOut">
               <a:rPr lang="en-US" smtClean="0"/>
-              <a:t>3/17/2026</a:t>
+              <a:t>3/18/2026</a:t>
             </a:fld>
             <a:endParaRPr lang="en-US"/>
           </a:p>
@@ -1901,7 +1901,7 @@
           <a:p>
             <a:fld id="{5BCAD085-E8A6-8845-BD4E-CB4CCA059FC4}" type="datetimeFigureOut">
               <a:rPr lang="en-US" smtClean="0"/>
-              <a:t>3/17/2026</a:t>
+              <a:t>3/18/2026</a:t>
             </a:fld>
             <a:endParaRPr lang="en-US"/>
           </a:p>
@@ -1996,7 +1996,7 @@
           <a:p>
             <a:fld id="{5BCAD085-E8A6-8845-BD4E-CB4CCA059FC4}" type="datetimeFigureOut">
               <a:rPr lang="en-US" smtClean="0"/>
-              <a:t>3/17/2026</a:t>
+              <a:t>3/18/2026</a:t>
             </a:fld>
             <a:endParaRPr lang="en-US"/>
           </a:p>
@@ -2271,7 +2271,7 @@
           <a:p>
             <a:fld id="{5BCAD085-E8A6-8845-BD4E-CB4CCA059FC4}" type="datetimeFigureOut">
               <a:rPr lang="en-US" smtClean="0"/>
-              <a:t>3/17/2026</a:t>
+              <a:t>3/18/2026</a:t>
             </a:fld>
             <a:endParaRPr lang="en-US"/>
           </a:p>
@@ -2523,7 +2523,7 @@
           <a:p>
             <a:fld id="{5BCAD085-E8A6-8845-BD4E-CB4CCA059FC4}" type="datetimeFigureOut">
               <a:rPr lang="en-US" smtClean="0"/>
-              <a:t>3/17/2026</a:t>
+              <a:t>3/18/2026</a:t>
             </a:fld>
             <a:endParaRPr lang="en-US"/>
           </a:p>
@@ -2734,7 +2734,7 @@
           <a:p>
             <a:fld id="{5BCAD085-E8A6-8845-BD4E-CB4CCA059FC4}" type="datetimeFigureOut">
               <a:rPr lang="en-US" smtClean="0"/>
-              <a:t>3/17/2026</a:t>
+              <a:t>3/18/2026</a:t>
             </a:fld>
             <a:endParaRPr lang="en-US"/>
           </a:p>
@@ -3212,7 +3212,7 @@
         <p:spPr>
           <a:xfrm>
             <a:off x="914400" y="2743200"/>
-            <a:ext cx="10058400" cy="731520"/>
+            <a:ext cx="10058400" cy="452496"/>
           </a:xfrm>
           <a:prstGeom prst="rect">
             <a:avLst/>
@@ -3240,7 +3240,8 @@
               </a:defRPr>
             </a:pPr>
             <a:r>
-              <a:t>A Modern Approach to Quality Assurance for NAEP &amp; PIAAC</a:t>
+              <a:rPr dirty="0"/>
+              <a:t>A Modern Approach to Quality Assurance for NAEP</a:t>
             </a:r>
           </a:p>
         </p:txBody>
@@ -13055,7 +13056,7 @@
         <p:spPr>
           <a:xfrm>
             <a:off x="960120" y="2971800"/>
-            <a:ext cx="2011680" cy="1463040"/>
+            <a:ext cx="2011680" cy="957250"/>
           </a:xfrm>
           <a:prstGeom prst="rect">
             <a:avLst/>
@@ -13083,14 +13084,23 @@
               </a:defRPr>
             </a:pPr>
             <a:r>
+              <a:rPr dirty="0"/>
               <a:t>Click through every assessment</a:t>
             </a:r>
-            <a:br/>
-            <a:r>
+            <a:r>
+              <a:rPr lang="en-US" dirty="0"/>
+              <a:t> </a:t>
+            </a:r>
+            <a:r>
+              <a:rPr dirty="0"/>
               <a:t>item in every language, browser,</a:t>
             </a:r>
-            <a:br/>
-            <a:r>
+            <a:r>
+              <a:rPr lang="en-US" dirty="0"/>
+              <a:t> </a:t>
+            </a:r>
+            <a:r>
+              <a:rPr dirty="0"/>
               <a:t>and viewport combination</a:t>
             </a:r>
           </a:p>
@@ -13237,7 +13247,7 @@
         <p:spPr>
           <a:xfrm>
             <a:off x="3703320" y="2971800"/>
-            <a:ext cx="2011680" cy="1463040"/>
+            <a:ext cx="2011680" cy="957250"/>
           </a:xfrm>
           <a:prstGeom prst="rect">
             <a:avLst/>
@@ -13265,14 +13275,23 @@
               </a:defRPr>
             </a:pPr>
             <a:r>
+              <a:rPr dirty="0"/>
               <a:t>Manually inspect each screen</a:t>
             </a:r>
-            <a:br/>
-            <a:r>
+            <a:r>
+              <a:rPr lang="en-US" dirty="0"/>
+              <a:t> </a:t>
+            </a:r>
+            <a:r>
+              <a:rPr dirty="0"/>
               <a:t>for layout issues, missing</a:t>
             </a:r>
-            <a:br/>
-            <a:r>
+            <a:r>
+              <a:rPr lang="en-US" dirty="0"/>
+              <a:t> </a:t>
+            </a:r>
+            <a:r>
+              <a:rPr dirty="0"/>
               <a:t>content, and rendering artifacts</a:t>
             </a:r>
           </a:p>
@@ -13419,7 +13438,7 @@
         <p:spPr>
           <a:xfrm>
             <a:off x="6446520" y="2971800"/>
-            <a:ext cx="2011680" cy="1463040"/>
+            <a:ext cx="2011680" cy="1175258"/>
           </a:xfrm>
           <a:prstGeom prst="rect">
             <a:avLst/>
@@ -13447,14 +13466,22 @@
               </a:defRPr>
             </a:pPr>
             <a:r>
+              <a:rPr dirty="0"/>
               <a:t>Read every line of text looking</a:t>
             </a:r>
-            <a:br/>
-            <a:r>
+            <a:r>
+              <a:rPr lang="en-US" dirty="0"/>
+              <a:t> </a:t>
+            </a:r>
+            <a:r>
+              <a:rPr dirty="0"/>
               <a:t>for spelling errors, homophone</a:t>
             </a:r>
-            <a:br/>
-            <a:r>
+            <a:br>
+              <a:rPr dirty="0"/>
+            </a:br>
+            <a:r>
+              <a:rPr dirty="0"/>
               <a:t>misuse, and grammar issues</a:t>
             </a:r>
           </a:p>
@@ -13610,7 +13637,7 @@
         <p:spPr>
           <a:xfrm>
             <a:off x="9189720" y="2971800"/>
-            <a:ext cx="2011680" cy="1463040"/>
+            <a:ext cx="2011680" cy="957250"/>
           </a:xfrm>
           <a:prstGeom prst="rect">
             <a:avLst/>
@@ -13638,14 +13665,23 @@
               </a:defRPr>
             </a:pPr>
             <a:r>
+              <a:rPr dirty="0"/>
               <a:t>Track what's been tested in</a:t>
             </a:r>
-            <a:br/>
-            <a:r>
+            <a:r>
+              <a:rPr lang="en-US" dirty="0"/>
+              <a:t> </a:t>
+            </a:r>
+            <a:r>
+              <a:rPr dirty="0"/>
               <a:t>spreadsheets with no centralized</a:t>
             </a:r>
-            <a:br/>
-            <a:r>
+            <a:r>
+              <a:rPr lang="en-US" dirty="0"/>
+              <a:t> </a:t>
+            </a:r>
+            <a:r>
+              <a:rPr dirty="0"/>
               <a:t>visibility or trend analysis</a:t>
             </a:r>
           </a:p>
@@ -13708,7 +13744,7 @@
         <p:spPr>
           <a:xfrm>
             <a:off x="731520" y="5120640"/>
-            <a:ext cx="2468880" cy="548640"/>
+            <a:ext cx="2468880" cy="643766"/>
           </a:xfrm>
           <a:prstGeom prst="rect">
             <a:avLst/>
@@ -13736,7 +13772,16 @@
               </a:defRPr>
             </a:pPr>
             <a:r>
-              <a:t>100s</a:t>
+              <a:rPr dirty="0"/>
+              <a:t>100</a:t>
+            </a:r>
+            <a:r>
+              <a:rPr lang="en-US" dirty="0"/>
+              <a:t>0</a:t>
+            </a:r>
+            <a:r>
+              <a:rPr dirty="0"/>
+              <a:t>s</a:t>
             </a:r>
           </a:p>
         </p:txBody>
@@ -13839,7 +13884,7 @@
         </p:nvSpPr>
         <p:spPr>
           <a:xfrm>
-            <a:off x="3474720" y="5120640"/>
+            <a:off x="3505201" y="5092251"/>
             <a:ext cx="2468880" cy="643766"/>
           </a:xfrm>
           <a:prstGeom prst="rect">
@@ -13869,12 +13914,9 @@
             </a:pPr>
             <a:r>
               <a:rPr lang="en-US" dirty="0"/>
-              <a:t>1</a:t>
-            </a:r>
-            <a:r>
-              <a:rPr dirty="0"/>
-              <a:t>20+</a:t>
-            </a:r>
+              <a:t>Multiple</a:t>
+            </a:r>
+            <a:endParaRPr dirty="0"/>
           </a:p>
         </p:txBody>
       </p:sp>
@@ -14914,6 +14956,7 @@
               </a:defRPr>
             </a:pPr>
             <a:r>
+              <a:rPr dirty="0"/>
               <a:t>Sounds Great, Right?</a:t>
             </a:r>
           </a:p>
@@ -14956,11 +14999,17 @@
               </a:defRPr>
             </a:pPr>
             <a:r>
+              <a:rPr dirty="0"/>
               <a:t>There's just one problem...</a:t>
             </a:r>
-            <a:br/>
-            <a:br/>
-            <a:r>
+            <a:br>
+              <a:rPr dirty="0"/>
+            </a:br>
+            <a:br>
+              <a:rPr dirty="0"/>
+            </a:br>
+            <a:r>
+              <a:rPr dirty="0"/>
               <a:t>Someone has to write the code.</a:t>
             </a:r>
           </a:p>
@@ -15013,6 +15062,146 @@
   <p:clrMapOvr>
     <a:masterClrMapping/>
   </p:clrMapOvr>
+  <p:timing>
+    <p:tnLst>
+      <p:par>
+        <p:cTn id="1" dur="indefinite" restart="never" nodeType="tmRoot">
+          <p:childTnLst>
+            <p:seq concurrent="1" nextAc="seek">
+              <p:cTn id="2" dur="indefinite" nodeType="mainSeq">
+                <p:childTnLst>
+                  <p:par>
+                    <p:cTn id="3" fill="hold">
+                      <p:stCondLst>
+                        <p:cond delay="indefinite"/>
+                      </p:stCondLst>
+                      <p:childTnLst>
+                        <p:par>
+                          <p:cTn id="4" fill="hold">
+                            <p:stCondLst>
+                              <p:cond delay="0"/>
+                            </p:stCondLst>
+                            <p:childTnLst>
+                              <p:par>
+                                <p:cTn id="5" presetID="10" presetClass="entr" presetSubtype="0" fill="hold" grpId="0" nodeType="clickEffect">
+                                  <p:stCondLst>
+                                    <p:cond delay="0"/>
+                                  </p:stCondLst>
+                                  <p:childTnLst>
+                                    <p:set>
+                                      <p:cBhvr>
+                                        <p:cTn id="6" dur="1" fill="hold">
+                                          <p:stCondLst>
+                                            <p:cond delay="0"/>
+                                          </p:stCondLst>
+                                        </p:cTn>
+                                        <p:tgtEl>
+                                          <p:spTgt spid="7"/>
+                                        </p:tgtEl>
+                                        <p:attrNameLst>
+                                          <p:attrName>style.visibility</p:attrName>
+                                        </p:attrNameLst>
+                                      </p:cBhvr>
+                                      <p:to>
+                                        <p:strVal val="visible"/>
+                                      </p:to>
+                                    </p:set>
+                                    <p:animEffect transition="in" filter="fade">
+                                      <p:cBhvr>
+                                        <p:cTn id="7" dur="500"/>
+                                        <p:tgtEl>
+                                          <p:spTgt spid="7"/>
+                                        </p:tgtEl>
+                                      </p:cBhvr>
+                                    </p:animEffect>
+                                  </p:childTnLst>
+                                </p:cTn>
+                              </p:par>
+                            </p:childTnLst>
+                          </p:cTn>
+                        </p:par>
+                      </p:childTnLst>
+                    </p:cTn>
+                  </p:par>
+                  <p:par>
+                    <p:cTn id="8" fill="hold">
+                      <p:stCondLst>
+                        <p:cond delay="indefinite"/>
+                      </p:stCondLst>
+                      <p:childTnLst>
+                        <p:par>
+                          <p:cTn id="9" fill="hold">
+                            <p:stCondLst>
+                              <p:cond delay="0"/>
+                            </p:stCondLst>
+                            <p:childTnLst>
+                              <p:par>
+                                <p:cTn id="10" presetID="10" presetClass="entr" presetSubtype="0" fill="hold" grpId="0" nodeType="clickEffect">
+                                  <p:stCondLst>
+                                    <p:cond delay="0"/>
+                                  </p:stCondLst>
+                                  <p:childTnLst>
+                                    <p:set>
+                                      <p:cBhvr>
+                                        <p:cTn id="11" dur="1" fill="hold">
+                                          <p:stCondLst>
+                                            <p:cond delay="0"/>
+                                          </p:stCondLst>
+                                        </p:cTn>
+                                        <p:tgtEl>
+                                          <p:spTgt spid="8"/>
+                                        </p:tgtEl>
+                                        <p:attrNameLst>
+                                          <p:attrName>style.visibility</p:attrName>
+                                        </p:attrNameLst>
+                                      </p:cBhvr>
+                                      <p:to>
+                                        <p:strVal val="visible"/>
+                                      </p:to>
+                                    </p:set>
+                                    <p:animEffect transition="in" filter="fade">
+                                      <p:cBhvr>
+                                        <p:cTn id="12" dur="500"/>
+                                        <p:tgtEl>
+                                          <p:spTgt spid="8"/>
+                                        </p:tgtEl>
+                                      </p:cBhvr>
+                                    </p:animEffect>
+                                  </p:childTnLst>
+                                </p:cTn>
+                              </p:par>
+                            </p:childTnLst>
+                          </p:cTn>
+                        </p:par>
+                      </p:childTnLst>
+                    </p:cTn>
+                  </p:par>
+                </p:childTnLst>
+              </p:cTn>
+              <p:prevCondLst>
+                <p:cond evt="onPrev" delay="0">
+                  <p:tgtEl>
+                    <p:sldTgt/>
+                  </p:tgtEl>
+                </p:cond>
+              </p:prevCondLst>
+              <p:nextCondLst>
+                <p:cond evt="onNext" delay="0">
+                  <p:tgtEl>
+                    <p:sldTgt/>
+                  </p:tgtEl>
+                </p:cond>
+              </p:nextCondLst>
+            </p:seq>
+          </p:childTnLst>
+        </p:cTn>
+      </p:par>
+    </p:tnLst>
+    <p:bldLst>
+      <p:bldP spid="7" grpId="0"/>
+      <p:bldP spid="8" grpId="0"/>
+    </p:bldLst>
+  </p:timing>
 </p:sld>
 </file>
 
@@ -15094,7 +15283,7 @@
         <p:spPr>
           <a:xfrm>
             <a:off x="731520" y="457200"/>
-            <a:ext cx="10058400" cy="731520"/>
+            <a:ext cx="10058400" cy="663387"/>
           </a:xfrm>
           <a:prstGeom prst="rect">
             <a:avLst/>
@@ -15122,7 +15311,24 @@
               </a:defRPr>
             </a:pPr>
             <a:r>
-              <a:t>What Your Team Would Need to Learn</a:t>
+              <a:rPr dirty="0"/>
+              <a:t>What </a:t>
+            </a:r>
+            <a:r>
+              <a:rPr lang="en-US" dirty="0"/>
+              <a:t>The </a:t>
+            </a:r>
+            <a:r>
+              <a:rPr dirty="0"/>
+              <a:t>Team Need</a:t>
+            </a:r>
+            <a:r>
+              <a:rPr lang="en-US" dirty="0"/>
+              <a:t>s</a:t>
+            </a:r>
+            <a:r>
+              <a:rPr dirty="0"/>
+              <a:t> to Learn</a:t>
             </a:r>
           </a:p>
         </p:txBody>
@@ -15310,7 +15516,7 @@
         <p:spPr>
           <a:xfrm>
             <a:off x="960120" y="2788920"/>
-            <a:ext cx="3017520" cy="1005840"/>
+            <a:ext cx="3017520" cy="739241"/>
           </a:xfrm>
           <a:prstGeom prst="rect">
             <a:avLst/>
@@ -15338,14 +15544,22 @@
               </a:defRPr>
             </a:pPr>
             <a:r>
+              <a:rPr dirty="0"/>
               <a:t>Learn the language: variables,</a:t>
             </a:r>
-            <a:br/>
-            <a:r>
+            <a:br>
+              <a:rPr dirty="0"/>
+            </a:br>
+            <a:r>
+              <a:rPr dirty="0"/>
               <a:t>functions, async/await,</a:t>
             </a:r>
-            <a:br/>
-            <a:r>
+            <a:r>
+              <a:rPr lang="en-US" dirty="0"/>
+              <a:t> </a:t>
+            </a:r>
+            <a:r>
+              <a:rPr dirty="0"/>
               <a:t>promises, error handling</a:t>
             </a:r>
           </a:p>
@@ -15492,7 +15706,7 @@
         <p:spPr>
           <a:xfrm>
             <a:off x="4617720" y="2788920"/>
-            <a:ext cx="3017520" cy="1005840"/>
+            <a:ext cx="3017520" cy="521233"/>
           </a:xfrm>
           <a:prstGeom prst="rect">
             <a:avLst/>
@@ -15520,14 +15734,35 @@
               </a:defRPr>
             </a:pPr>
             <a:r>
-              <a:t>npm, package.json,</a:t>
-            </a:r>
-            <a:br/>
-            <a:r>
+              <a:rPr dirty="0" err="1"/>
+              <a:t>npm</a:t>
+            </a:r>
+            <a:r>
+              <a:rPr dirty="0"/>
+              <a:t>, </a:t>
+            </a:r>
+            <a:r>
+              <a:rPr dirty="0" err="1"/>
+              <a:t>package.json</a:t>
+            </a:r>
+            <a:r>
+              <a:rPr dirty="0"/>
+              <a:t>,</a:t>
+            </a:r>
+            <a:r>
+              <a:rPr lang="en-US" dirty="0"/>
+              <a:t> </a:t>
+            </a:r>
+            <a:r>
+              <a:rPr dirty="0"/>
               <a:t>module systems, dependency</a:t>
             </a:r>
-            <a:br/>
-            <a:r>
+            <a:r>
+              <a:rPr lang="en-US" dirty="0"/>
+              <a:t> </a:t>
+            </a:r>
+            <a:r>
+              <a:rPr dirty="0"/>
               <a:t>management</a:t>
             </a:r>
           </a:p>
@@ -15674,7 +15909,7 @@
         <p:spPr>
           <a:xfrm>
             <a:off x="8275320" y="2788920"/>
-            <a:ext cx="3017520" cy="1005840"/>
+            <a:ext cx="3017520" cy="521233"/>
           </a:xfrm>
           <a:prstGeom prst="rect">
             <a:avLst/>
@@ -15702,14 +15937,27 @@
               </a:defRPr>
             </a:pPr>
             <a:r>
+              <a:rPr dirty="0"/>
               <a:t>Navigate complex DOM trees,</a:t>
             </a:r>
-            <a:br/>
-            <a:r>
-              <a:t>iframes, shadow DOM,</a:t>
-            </a:r>
-            <a:br/>
-            <a:r>
+            <a:r>
+              <a:rPr lang="en-US" dirty="0"/>
+              <a:t> </a:t>
+            </a:r>
+            <a:r>
+              <a:rPr dirty="0" err="1"/>
+              <a:t>iframes</a:t>
+            </a:r>
+            <a:r>
+              <a:rPr dirty="0"/>
+              <a:t>, shadow DOM,</a:t>
+            </a:r>
+            <a:r>
+              <a:rPr lang="en-US" dirty="0"/>
+              <a:t> </a:t>
+            </a:r>
+            <a:r>
+              <a:rPr dirty="0"/>
               <a:t>custom elements</a:t>
             </a:r>
           </a:p>
@@ -15856,7 +16104,7 @@
         <p:spPr>
           <a:xfrm>
             <a:off x="960120" y="5074920"/>
-            <a:ext cx="3017520" cy="1005840"/>
+            <a:ext cx="3017520" cy="521233"/>
           </a:xfrm>
           <a:prstGeom prst="rect">
             <a:avLst/>
@@ -15884,14 +16132,23 @@
               </a:defRPr>
             </a:pPr>
             <a:r>
+              <a:rPr dirty="0"/>
               <a:t>Page objects, locators,</a:t>
             </a:r>
-            <a:br/>
-            <a:r>
+            <a:r>
+              <a:rPr lang="en-US" dirty="0"/>
+              <a:t> </a:t>
+            </a:r>
+            <a:r>
+              <a:rPr dirty="0"/>
               <a:t>assertions, test fixtures,</a:t>
             </a:r>
-            <a:br/>
-            <a:r>
+            <a:r>
+              <a:rPr lang="en-US" dirty="0"/>
+              <a:t> </a:t>
+            </a:r>
+            <a:r>
+              <a:rPr dirty="0"/>
               <a:t>browser contexts</a:t>
             </a:r>
           </a:p>
@@ -16038,7 +16295,7 @@
         <p:spPr>
           <a:xfrm>
             <a:off x="4617720" y="5074920"/>
-            <a:ext cx="3017520" cy="1005840"/>
+            <a:ext cx="3017520" cy="521233"/>
           </a:xfrm>
           <a:prstGeom prst="rect">
             <a:avLst/>
@@ -16066,14 +16323,23 @@
               </a:defRPr>
             </a:pPr>
             <a:r>
+              <a:rPr dirty="0"/>
               <a:t>Terminal operations, env</a:t>
             </a:r>
-            <a:br/>
-            <a:r>
+            <a:r>
+              <a:rPr lang="en-US" dirty="0"/>
+              <a:t> </a:t>
+            </a:r>
+            <a:r>
+              <a:rPr dirty="0"/>
               <a:t>variables, CI/CD pipelines,</a:t>
             </a:r>
-            <a:br/>
-            <a:r>
+            <a:r>
+              <a:rPr lang="en-US" dirty="0"/>
+              <a:t> </a:t>
+            </a:r>
+            <a:r>
+              <a:rPr dirty="0"/>
               <a:t>debugging tools</a:t>
             </a:r>
           </a:p>
@@ -16220,7 +16486,7 @@
         <p:spPr>
           <a:xfrm>
             <a:off x="8275320" y="5074920"/>
-            <a:ext cx="3017520" cy="1005840"/>
+            <a:ext cx="3017520" cy="521233"/>
           </a:xfrm>
           <a:prstGeom prst="rect">
             <a:avLst/>
@@ -16248,14 +16514,22 @@
               </a:defRPr>
             </a:pPr>
             <a:r>
+              <a:rPr dirty="0"/>
               <a:t>Page Object Model, helpers,</a:t>
             </a:r>
-            <a:br/>
-            <a:r>
+            <a:br>
+              <a:rPr dirty="0"/>
+            </a:br>
+            <a:r>
+              <a:rPr dirty="0"/>
               <a:t>reporters, data-driven</a:t>
             </a:r>
-            <a:br/>
-            <a:r>
+            <a:r>
+              <a:rPr lang="en-US" dirty="0"/>
+              <a:t> </a:t>
+            </a:r>
+            <a:r>
+              <a:rPr dirty="0"/>
               <a:t>testing patterns</a:t>
             </a:r>
           </a:p>
@@ -19013,7 +19287,7 @@
         <p:spPr>
           <a:xfrm>
             <a:off x="731520" y="457200"/>
-            <a:ext cx="10058400" cy="731520"/>
+            <a:ext cx="10058400" cy="663387"/>
           </a:xfrm>
           <a:prstGeom prst="rect">
             <a:avLst/>
@@ -19041,8 +19315,18 @@
               </a:defRPr>
             </a:pPr>
             <a:r>
+              <a:rPr dirty="0"/>
               <a:t>The Reality</a:t>
             </a:r>
+            <a:r>
+              <a:rPr lang="en-US" dirty="0"/>
+              <a:t> of Adding </a:t>
+            </a:r>
+            <a:r>
+              <a:rPr lang="en-US"/>
+              <a:t>An Assessment</a:t>
+            </a:r>
+            <a:endParaRPr/>
           </a:p>
         </p:txBody>
       </p:sp>
@@ -19187,7 +19471,7 @@
         <p:spPr>
           <a:xfrm>
             <a:off x="914400" y="2926080"/>
-            <a:ext cx="2103120" cy="914400"/>
+            <a:ext cx="2103120" cy="521233"/>
           </a:xfrm>
           <a:prstGeom prst="rect">
             <a:avLst/>
@@ -19215,10 +19499,15 @@
               </a:defRPr>
             </a:pPr>
             <a:r>
+              <a:rPr dirty="0"/>
               <a:t>1,600+ lines of custom utility</a:t>
             </a:r>
-            <a:br/>
-            <a:r>
+            <a:r>
+              <a:rPr lang="en-US" dirty="0"/>
+              <a:t> </a:t>
+            </a:r>
+            <a:r>
+              <a:rPr dirty="0"/>
               <a:t>code to maintain</a:t>
             </a:r>
           </a:p>
@@ -19862,6 +20151,7 @@
               </a:defRPr>
             </a:pPr>
             <a:r>
+              <a:rPr dirty="0"/>
               <a:t>There is.</a:t>
             </a:r>
           </a:p>
@@ -19872,6 +20162,146 @@
   <p:clrMapOvr>
     <a:masterClrMapping/>
   </p:clrMapOvr>
+  <p:timing>
+    <p:tnLst>
+      <p:par>
+        <p:cTn id="1" dur="indefinite" restart="never" nodeType="tmRoot">
+          <p:childTnLst>
+            <p:seq concurrent="1" nextAc="seek">
+              <p:cTn id="2" dur="indefinite" nodeType="mainSeq">
+                <p:childTnLst>
+                  <p:par>
+                    <p:cTn id="3" fill="hold">
+                      <p:stCondLst>
+                        <p:cond delay="indefinite"/>
+                      </p:stCondLst>
+                      <p:childTnLst>
+                        <p:par>
+                          <p:cTn id="4" fill="hold">
+                            <p:stCondLst>
+                              <p:cond delay="0"/>
+                            </p:stCondLst>
+                            <p:childTnLst>
+                              <p:par>
+                                <p:cTn id="5" presetID="10" presetClass="entr" presetSubtype="0" fill="hold" grpId="0" nodeType="clickEffect">
+                                  <p:stCondLst>
+                                    <p:cond delay="0"/>
+                                  </p:stCondLst>
+                                  <p:childTnLst>
+                                    <p:set>
+                                      <p:cBhvr>
+                                        <p:cTn id="6" dur="1" fill="hold">
+                                          <p:stCondLst>
+                                            <p:cond delay="0"/>
+                                          </p:stCondLst>
+                                        </p:cTn>
+                                        <p:tgtEl>
+                                          <p:spTgt spid="20"/>
+                                        </p:tgtEl>
+                                        <p:attrNameLst>
+                                          <p:attrName>style.visibility</p:attrName>
+                                        </p:attrNameLst>
+                                      </p:cBhvr>
+                                      <p:to>
+                                        <p:strVal val="visible"/>
+                                      </p:to>
+                                    </p:set>
+                                    <p:animEffect transition="in" filter="fade">
+                                      <p:cBhvr>
+                                        <p:cTn id="7" dur="500"/>
+                                        <p:tgtEl>
+                                          <p:spTgt spid="20"/>
+                                        </p:tgtEl>
+                                      </p:cBhvr>
+                                    </p:animEffect>
+                                  </p:childTnLst>
+                                </p:cTn>
+                              </p:par>
+                            </p:childTnLst>
+                          </p:cTn>
+                        </p:par>
+                      </p:childTnLst>
+                    </p:cTn>
+                  </p:par>
+                  <p:par>
+                    <p:cTn id="8" fill="hold">
+                      <p:stCondLst>
+                        <p:cond delay="indefinite"/>
+                      </p:stCondLst>
+                      <p:childTnLst>
+                        <p:par>
+                          <p:cTn id="9" fill="hold">
+                            <p:stCondLst>
+                              <p:cond delay="0"/>
+                            </p:stCondLst>
+                            <p:childTnLst>
+                              <p:par>
+                                <p:cTn id="10" presetID="10" presetClass="entr" presetSubtype="0" fill="hold" grpId="0" nodeType="clickEffect">
+                                  <p:stCondLst>
+                                    <p:cond delay="0"/>
+                                  </p:stCondLst>
+                                  <p:childTnLst>
+                                    <p:set>
+                                      <p:cBhvr>
+                                        <p:cTn id="11" dur="1" fill="hold">
+                                          <p:stCondLst>
+                                            <p:cond delay="0"/>
+                                          </p:stCondLst>
+                                        </p:cTn>
+                                        <p:tgtEl>
+                                          <p:spTgt spid="21"/>
+                                        </p:tgtEl>
+                                        <p:attrNameLst>
+                                          <p:attrName>style.visibility</p:attrName>
+                                        </p:attrNameLst>
+                                      </p:cBhvr>
+                                      <p:to>
+                                        <p:strVal val="visible"/>
+                                      </p:to>
+                                    </p:set>
+                                    <p:animEffect transition="in" filter="fade">
+                                      <p:cBhvr>
+                                        <p:cTn id="12" dur="500"/>
+                                        <p:tgtEl>
+                                          <p:spTgt spid="21"/>
+                                        </p:tgtEl>
+                                      </p:cBhvr>
+                                    </p:animEffect>
+                                  </p:childTnLst>
+                                </p:cTn>
+                              </p:par>
+                            </p:childTnLst>
+                          </p:cTn>
+                        </p:par>
+                      </p:childTnLst>
+                    </p:cTn>
+                  </p:par>
+                </p:childTnLst>
+              </p:cTn>
+              <p:prevCondLst>
+                <p:cond evt="onPrev" delay="0">
+                  <p:tgtEl>
+                    <p:sldTgt/>
+                  </p:tgtEl>
+                </p:cond>
+              </p:prevCondLst>
+              <p:nextCondLst>
+                <p:cond evt="onNext" delay="0">
+                  <p:tgtEl>
+                    <p:sldTgt/>
+                  </p:tgtEl>
+                </p:cond>
+              </p:nextCondLst>
+            </p:seq>
+          </p:childTnLst>
+        </p:cTn>
+      </p:par>
+    </p:tnLst>
+    <p:bldLst>
+      <p:bldP spid="20" grpId="0"/>
+      <p:bldP spid="21" grpId="0"/>
+    </p:bldLst>
+  </p:timing>
 </p:sld>
 </file>
 

</xml_diff>